<commit_message>
Add Lalit Rawat (3:35 PM), all speakers confirmed, event ends 4:10 PM; deck build tools
- Host deck: Lalit's intro slide, 12-session agenda, 13 speakers / 11 MVPs, 9:00 AM - 4:10 PM
- README, schedule, calendar and run of show regenerated
- tools/: scripts that rebuild the decks and docs from the website data

Co-Authored-By: Claude Opus 5.5 <noreply@anthropic.com>
</commit_message>
<xml_diff>
--- a/slides/agentic-ai-summit-2026-speaker-template.pptx
+++ b/slides/agentic-ai-summit-2026-speaker-template.pptx
@@ -114,14 +114,14 @@
   <p:extLst>
     <p:ext uri="{521415D9-36F7-43E2-AB2F-B90AF26B5E84}">
       <p14:sectionLst xmlns:p14="http://schemas.microsoft.com/office/powerpoint/2010/main">
-        <p14:section name="Start" id="{8d8a4c7f-8c6d-4e4f-daae-64c15821e1c5}">
+        <p14:section name="Start" id="{34bc9ed1-87a8-2528-aa83-722c34e8b904}">
           <p14:sldIdLst>
             <p14:sldId id="256"/>
             <p14:sldId id="257"/>
             <p14:sldId id="258"/>
           </p14:sldIdLst>
         </p14:section>
-        <p14:section name="Content" id="{f1c409e8-0a44-c121-b916-620a9f3005dc}">
+        <p14:section name="Content" id="{b843d2ff-90cb-2b05-c7f6-3f5674e2b707}">
           <p14:sldIdLst>
             <p14:sldId id="259"/>
             <p14:sldId id="260"/>
@@ -129,7 +129,7 @@
             <p14:sldId id="262"/>
           </p14:sldIdLst>
         </p14:section>
-        <p14:section name="End" id="{527fff91-ae8b-ab53-2f80-39a5dcf3ea6d}">
+        <p14:section name="End" id="{c0a858f0-9972-abef-f3ca-1d8d1667700f}">
           <p14:sldIdLst>
             <p14:sldId id="263"/>
           </p14:sldIdLst>
@@ -1259,7 +1259,7 @@
       </p:grpSpPr>
       <p:pic>
         <p:nvPicPr>
-          <p:cNvPr id="2" name="Image 0" descr="/private/tmp/claude-501/-Users-prathapreddy/3ec54f73-b068-451c-a6c4-a4ac3fd4b079/scratchpad/summit/assets/itc-logo.png">    </p:cNvPr>
+          <p:cNvPr id="2" name="Image 0" descr="/Users/prathapreddy/agentic-ai-summit-2026/tools/.cache/assets/itc-logo.png">    </p:cNvPr>
           <p:cNvPicPr>
             <a:picLocks noChangeAspect="1"/>
           </p:cNvPicPr>
@@ -1319,7 +1319,7 @@
       </p:sp>
       <p:pic>
         <p:nvPicPr>
-          <p:cNvPr id="4" name="Image 1" descr="/private/tmp/claude-501/-Users-prathapreddy/3ec54f73-b068-451c-a6c4-a4ac3fd4b079/scratchpad/summit/assets/poster.png">    </p:cNvPr>
+          <p:cNvPr id="4" name="Image 1" descr="/Users/prathapreddy/agentic-ai-summit-2026/tools/.cache/assets/poster.png">    </p:cNvPr>
           <p:cNvPicPr>
             <a:picLocks noChangeAspect="1"/>
           </p:cNvPicPr>
@@ -1476,7 +1476,7 @@
       </p:grpSpPr>
       <p:pic>
         <p:nvPicPr>
-          <p:cNvPr id="2" name="Image 0" descr="/private/tmp/claude-501/-Users-prathapreddy/3ec54f73-b068-451c-a6c4-a4ac3fd4b079/scratchpad/summit/assets/itc-logo.png">    </p:cNvPr>
+          <p:cNvPr id="2" name="Image 0" descr="/Users/prathapreddy/agentic-ai-summit-2026/tools/.cache/assets/itc-logo.png">    </p:cNvPr>
           <p:cNvPicPr>
             <a:picLocks noChangeAspect="1"/>
           </p:cNvPicPr>
@@ -1669,7 +1669,7 @@
       </p:sp>
       <p:pic>
         <p:nvPicPr>
-          <p:cNvPr id="3" name="Image 0" descr="/private/tmp/claude-501/-Users-prathapreddy/3ec54f73-b068-451c-a6c4-a4ac3fd4b079/scratchpad/summit/assets/itc-logo.png">    </p:cNvPr>
+          <p:cNvPr id="3" name="Image 0" descr="/Users/prathapreddy/agentic-ai-summit-2026/tools/.cache/assets/itc-logo.png">    </p:cNvPr>
           <p:cNvPicPr>
             <a:picLocks noChangeAspect="1"/>
           </p:cNvPicPr>
@@ -1907,7 +1907,7 @@
       </p:sp>
       <p:pic>
         <p:nvPicPr>
-          <p:cNvPr id="3" name="Image 0" descr="/private/tmp/claude-501/-Users-prathapreddy/3ec54f73-b068-451c-a6c4-a4ac3fd4b079/scratchpad/summit/assets/itc-logo.png">    </p:cNvPr>
+          <p:cNvPr id="3" name="Image 0" descr="/Users/prathapreddy/agentic-ai-summit-2026/tools/.cache/assets/itc-logo.png">    </p:cNvPr>
           <p:cNvPicPr>
             <a:picLocks noChangeAspect="1"/>
           </p:cNvPicPr>
@@ -2212,7 +2212,7 @@
       </p:sp>
       <p:pic>
         <p:nvPicPr>
-          <p:cNvPr id="3" name="Image 0" descr="/private/tmp/claude-501/-Users-prathapreddy/3ec54f73-b068-451c-a6c4-a4ac3fd4b079/scratchpad/summit/assets/itc-logo.png">    </p:cNvPr>
+          <p:cNvPr id="3" name="Image 0" descr="/Users/prathapreddy/agentic-ai-summit-2026/tools/.cache/assets/itc-logo.png">    </p:cNvPr>
           <p:cNvPicPr>
             <a:picLocks noChangeAspect="1"/>
           </p:cNvPicPr>
@@ -2403,7 +2403,7 @@
       </p:sp>
       <p:pic>
         <p:nvPicPr>
-          <p:cNvPr id="3" name="Image 0" descr="/private/tmp/claude-501/-Users-prathapreddy/3ec54f73-b068-451c-a6c4-a4ac3fd4b079/scratchpad/summit/assets/itc-logo.png">    </p:cNvPr>
+          <p:cNvPr id="3" name="Image 0" descr="/Users/prathapreddy/agentic-ai-summit-2026/tools/.cache/assets/itc-logo.png">    </p:cNvPr>
           <p:cNvPicPr>
             <a:picLocks noChangeAspect="1"/>
           </p:cNvPicPr>
@@ -2667,7 +2667,7 @@
       </p:sp>
       <p:pic>
         <p:nvPicPr>
-          <p:cNvPr id="3" name="Image 0" descr="/private/tmp/claude-501/-Users-prathapreddy/3ec54f73-b068-451c-a6c4-a4ac3fd4b079/scratchpad/summit/assets/itc-logo.png">    </p:cNvPr>
+          <p:cNvPr id="3" name="Image 0" descr="/Users/prathapreddy/agentic-ai-summit-2026/tools/.cache/assets/itc-logo.png">    </p:cNvPr>
           <p:cNvPicPr>
             <a:picLocks noChangeAspect="1"/>
           </p:cNvPicPr>
@@ -2738,7 +2738,7 @@
       </p:sp>
       <p:pic>
         <p:nvPicPr>
-          <p:cNvPr id="5" name="Image 1" descr="/private/tmp/claude-501/-Users-prathapreddy/3ec54f73-b068-451c-a6c4-a4ac3fd4b079/scratchpad/summit/build/img/ph-empty.png">    </p:cNvPr>
+          <p:cNvPr id="5" name="Image 1" descr="/Users/prathapreddy/agentic-ai-summit-2026/tools/.cache/img/ph-empty.png">    </p:cNvPr>
           <p:cNvPicPr>
             <a:picLocks noChangeAspect="1"/>
           </p:cNvPicPr>
@@ -2940,7 +2940,7 @@
       </p:grpSpPr>
       <p:pic>
         <p:nvPicPr>
-          <p:cNvPr id="2" name="Image 0" descr="/private/tmp/claude-501/-Users-prathapreddy/3ec54f73-b068-451c-a6c4-a4ac3fd4b079/scratchpad/summit/assets/itc-logo.png">    </p:cNvPr>
+          <p:cNvPr id="2" name="Image 0" descr="/Users/prathapreddy/agentic-ai-summit-2026/tools/.cache/assets/itc-logo.png">    </p:cNvPr>
           <p:cNvPicPr>
             <a:picLocks noChangeAspect="1"/>
           </p:cNvPicPr>
@@ -2964,7 +2964,7 @@
       </p:pic>
       <p:pic>
         <p:nvPicPr>
-          <p:cNvPr id="3" name="Image 1" descr="/private/tmp/claude-501/-Users-prathapreddy/3ec54f73-b068-451c-a6c4-a4ac3fd4b079/scratchpad/summit/assets/cat-wave.png">    </p:cNvPr>
+          <p:cNvPr id="3" name="Image 1" descr="/Users/prathapreddy/agentic-ai-summit-2026/tools/.cache/assets/cat-wave.png">    </p:cNvPr>
           <p:cNvPicPr>
             <a:picLocks noChangeAspect="1"/>
           </p:cNvPicPr>
@@ -4858,7 +4858,7 @@
       </p:sp>
       <p:pic>
         <p:nvPicPr>
-          <p:cNvPr id="5" name="Takeaway icon 1" descr="/private/tmp/claude-501/-Users-prathapreddy/3ec54f73-b068-451c-a6c4-a4ac3fd4b079/scratchpad/summit/build/img/ic-bulb-w.png">    </p:cNvPr>
+          <p:cNvPr id="5" name="Takeaway icon 1" descr="/Users/prathapreddy/agentic-ai-summit-2026/tools/.cache/img/ic-bulb-w.png">    </p:cNvPr>
           <p:cNvPicPr>
             <a:picLocks noChangeAspect="1"/>
           </p:cNvPicPr>
@@ -4999,7 +4999,7 @@
       </p:sp>
       <p:pic>
         <p:nvPicPr>
-          <p:cNvPr id="10" name="Takeaway icon 2" descr="/private/tmp/claude-501/-Users-prathapreddy/3ec54f73-b068-451c-a6c4-a4ac3fd4b079/scratchpad/summit/build/img/ic-rocket-w.png">    </p:cNvPr>
+          <p:cNvPr id="10" name="Takeaway icon 2" descr="/Users/prathapreddy/agentic-ai-summit-2026/tools/.cache/img/ic-rocket-w.png">    </p:cNvPr>
           <p:cNvPicPr>
             <a:picLocks noChangeAspect="1"/>
           </p:cNvPicPr>
@@ -5140,7 +5140,7 @@
       </p:sp>
       <p:pic>
         <p:nvPicPr>
-          <p:cNvPr id="15" name="Takeaway icon 3" descr="/private/tmp/claude-501/-Users-prathapreddy/3ec54f73-b068-451c-a6c4-a4ac3fd4b079/scratchpad/summit/build/img/ic-globe-w.png">    </p:cNvPr>
+          <p:cNvPr id="15" name="Takeaway icon 3" descr="/Users/prathapreddy/agentic-ai-summit-2026/tools/.cache/img/ic-globe-w.png">    </p:cNvPr>
           <p:cNvPicPr>
             <a:picLocks noChangeAspect="1"/>
           </p:cNvPicPr>
@@ -5420,7 +5420,7 @@
 </file>
 
 <file path=ppt/theme/theme1.xml><?xml version="1.0" encoding="utf-8"?>
-<a:theme xmlns:a="http://schemas.openxmlformats.org/drawingml/2006/main" name="Agentic AI Summit 2026">
+<a:theme xmlns:a="http://schemas.openxmlformats.org/drawingml/2006/main" name="Office Theme">
   <a:themeElements>
     <a:clrScheme name="Agentic AI Summit 2026">
       <a:dk1>
@@ -5460,7 +5460,7 @@
         <a:srgbClr val="7C3AED"/>
       </a:folHlink>
     </a:clrScheme>
-    <a:fontScheme name="Agentic AI Summit 2026">
+    <a:fontScheme name="Office">
       <a:majorFont>
         <a:latin typeface="Arial"/>
         <a:ea typeface=""/>

</xml_diff>